<commit_message>
añadidos de casos de uso, diagrams de secuencia y clases
</commit_message>
<xml_diff>
--- a/presentacion/Presentacion_Atlantic_City_UML.pptx
+++ b/presentacion/Presentacion_Atlantic_City_UML.pptx
@@ -6289,7 +6289,7 @@
         <p:spPr>
           <a:xfrm>
             <a:off x="640080" y="1371600"/>
-            <a:ext cx="6949440" cy="5620871"/>
+            <a:ext cx="6949440" cy="5008256"/>
           </a:xfrm>
           <a:prstGeom prst="rect">
             <a:avLst/>
@@ -9792,7 +9792,7 @@
         <p:spPr>
           <a:xfrm>
             <a:off x="640080" y="1371600"/>
-            <a:ext cx="6858000" cy="4174435"/>
+            <a:ext cx="6858000" cy="4511216"/>
           </a:xfrm>
           <a:prstGeom prst="rect">
             <a:avLst/>

</xml_diff>